<commit_message>
Apresentação: sincroniza v2 após gravação local
Co-authored-by: Cursor <cursoragent@cursor.com>
</commit_message>
<xml_diff>
--- a/reports/Apresentacao_NPS_Fase1 v2.pptx
+++ b/reports/Apresentacao_NPS_Fase1 v2.pptx
@@ -5289,7 +5289,7 @@
         </p:nvSpPr>
         <p:spPr>
           <a:xfrm>
-            <a:off x="816275" y="0"/>
+            <a:off x="816275" y="132093"/>
             <a:ext cx="7511451" cy="1143000"/>
           </a:xfrm>
         </p:spPr>
@@ -5382,7 +5382,7 @@
         </p:blipFill>
         <p:spPr>
           <a:xfrm>
-            <a:off x="2803584" y="2767023"/>
+            <a:off x="2803584" y="2986098"/>
             <a:ext cx="3536831" cy="3522375"/>
           </a:xfrm>
           <a:prstGeom prst="rect">

</xml_diff>